<commit_message>
<PackageVersion Include="DeterministicIoPackaging" Version="0.25.0" />
</commit_message>
<xml_diff>
--- a/src/Tests.ImageSharp/Samples.VerifyPowerpoint.verified.pptx
+++ b/src/Tests.ImageSharp/Samples.VerifyPowerpoint.verified.pptx
@@ -2,10 +2,10 @@
 <file path=ppt/presentation.xml><?xml version="1.0" encoding="utf-8"?>
 <p:presentation xmlns:p="http://schemas.openxmlformats.org/presentationml/2006/main">
   <p:sldMasterIdLst>
-    <p:sldMasterId xmlns:r="http://schemas.openxmlformats.org/officeDocument/2006/relationships" id="2147483648" r:id="smRid1"/>
+    <p:sldMasterId xmlns:r="http://schemas.openxmlformats.org/officeDocument/2006/relationships" id="2147483648" r:id="DeterministicId2"/>
   </p:sldMasterIdLst>
   <p:sldIdLst>
-    <p:sldId xmlns:r="http://schemas.openxmlformats.org/officeDocument/2006/relationships" id="256" r:id="sldRid1"/>
+    <p:sldId xmlns:r="http://schemas.openxmlformats.org/officeDocument/2006/relationships" id="256" r:id="DeterministicId1"/>
   </p:sldIdLst>
   <p:sldSz cx="9144000" cy="6858000"/>
   <p:notesSz cx="6858000" cy="9144000"/>
@@ -53,7 +53,7 @@
   </p:cSld>
   <p:clrMap bg1="lt1" tx1="dk1" bg2="lt2" tx2="dk2" accent1="accent1" accent2="accent2" accent3="accent3" accent4="accent4" accent5="accent5" accent6="accent6" hlink="hlink" folHlink="folHlink"/>
   <p:sldLayoutIdLst>
-    <p:sldLayoutId xmlns:r="http://schemas.openxmlformats.org/officeDocument/2006/relationships" id="2147483649" r:id="slRid1"/>
+    <p:sldLayoutId xmlns:r="http://schemas.openxmlformats.org/officeDocument/2006/relationships" id="2147483649" r:id="DeterministicId1"/>
   </p:sldLayoutIdLst>
 </p:sldMaster>
 </file>

</xml_diff>

<commit_message>
Move the pptx theme to Aptos
sample.pptx's theme named Calibri, which src/Fonts does not carry, so the deck
resolved it from the OS the way the workbooks resolved Arial before the last
commit. It was the only fixture left doing so.

With it moved, the whole suite renders from the bundled fonts alone: pinning
FontDirectory to src/Fonts, which skips system fonts entirely and throws on a
missing face, reproduces every verified png across all three test directories
with nothing received. Word, Excel and PowerPoint alike now depend on files the
repo carries rather than on what the machine happens to have installed.

Only the pptx and png targets move. The text targets are unchanged.
</commit_message>
<xml_diff>
--- a/src/Tests.ImageSharp/Samples.VerifyPowerpoint.verified.pptx
+++ b/src/Tests.ImageSharp/Samples.VerifyPowerpoint.verified.pptx
@@ -101,12 +101,12 @@
     </a:clrScheme>
     <a:fontScheme name="Office">
       <a:majorFont>
-        <a:latin typeface="Calibri"/>
+        <a:latin typeface="Aptos"/>
         <a:ea typeface=""/>
         <a:cs typeface=""/>
       </a:majorFont>
       <a:minorFont>
-        <a:latin typeface="Calibri"/>
+        <a:latin typeface="Aptos"/>
         <a:ea typeface=""/>
         <a:cs typeface=""/>
       </a:minorFont>

</xml_diff>